<commit_message>
Polish the neutral-atom explanation and synchronize slide exports
</commit_message>
<xml_diff>
--- a/presentations/DuQuantum_Pasqal_7min.pptx
+++ b/presentations/DuQuantum_Pasqal_7min.pptx
@@ -11995,7 +11995,7 @@
             <a:tbl>
               <a:tblPr>
                 <a:noFill/>
-                <a:tableStyleId>{2A7FEDC0-A9D9-4AC4-95FF-5C3F1438AFD2}</a:tableStyleId>
+                <a:tableStyleId>{AC2704FD-A5F2-42A0-AE05-B1BCB4C8DE3E}</a:tableStyleId>
               </a:tblPr>
               <a:tblGrid>
                 <a:gridCol w="6000750"/>
@@ -13636,7 +13636,7 @@
             <a:tbl>
               <a:tblPr>
                 <a:noFill/>
-                <a:tableStyleId>{2A7FEDC0-A9D9-4AC4-95FF-5C3F1438AFD2}</a:tableStyleId>
+                <a:tableStyleId>{AC2704FD-A5F2-42A0-AE05-B1BCB4C8DE3E}</a:tableStyleId>
               </a:tblPr>
               <a:tblGrid>
                 <a:gridCol w="3524250"/>
@@ -16168,7 +16168,7 @@
         <p:spPr>
           <a:xfrm>
             <a:off x="609600" y="3838575"/>
-            <a:ext cx="5238750" cy="923925"/>
+            <a:ext cx="5238900" cy="1047900"/>
           </a:xfrm>
           <a:prstGeom prst="rect">
             <a:avLst/>
@@ -16185,6 +16185,9 @@
           <a:lstStyle/>
           <a:p>
             <a:pPr indent="0" lvl="0" marL="0" marR="0" rtl="0" algn="l">
+              <a:lnSpc>
+                <a:spcPct val="105000"/>
+              </a:lnSpc>
               <a:spcBef>
                 <a:spcPts val="0"/>
               </a:spcBef>
@@ -16199,23 +16202,7 @@
                   <a:srgbClr val="15263B"/>
                 </a:solidFill>
               </a:rPr>
-              <a:t>Rydberg interactions allow the system to enter a ground state </a:t>
-            </a:r>
-            <a:r>
-              <a:rPr lang="en-US" sz="2100">
-                <a:solidFill>
-                  <a:srgbClr val="15263B"/>
-                </a:solidFill>
-              </a:rPr>
-              <a:t>mimicking</a:t>
-            </a:r>
-            <a:r>
-              <a:rPr lang="en-US" sz="2100">
-                <a:solidFill>
-                  <a:srgbClr val="15263B"/>
-                </a:solidFill>
-              </a:rPr>
-              <a:t> the ideal </a:t>
+              <a:t>Rydberg interactions set pairwise costs. Lasers set selection costs and drive state preparation.</a:t>
             </a:r>
             <a:endParaRPr sz="2100">
               <a:solidFill>
@@ -16499,7 +16486,7 @@
             <a:tbl>
               <a:tblPr>
                 <a:noFill/>
-                <a:tableStyleId>{2A7FEDC0-A9D9-4AC4-95FF-5C3F1438AFD2}</a:tableStyleId>
+                <a:tableStyleId>{AC2704FD-A5F2-42A0-AE05-B1BCB4C8DE3E}</a:tableStyleId>
               </a:tblPr>
               <a:tblGrid>
                 <a:gridCol w="742950"/>
@@ -19347,7 +19334,7 @@
             <a:tbl>
               <a:tblPr>
                 <a:noFill/>
-                <a:tableStyleId>{2A7FEDC0-A9D9-4AC4-95FF-5C3F1438AFD2}</a:tableStyleId>
+                <a:tableStyleId>{AC2704FD-A5F2-42A0-AE05-B1BCB4C8DE3E}</a:tableStyleId>
               </a:tblPr>
               <a:tblGrid>
                 <a:gridCol w="4191000"/>

</xml_diff>